<commit_message>
Update the submission deck: sign-up is built, test count, who the sellers are
- Slide 10: chat sign-up is built; the payment provider's identity check is not.
- Slide 11: "560+ automated tests" instead of 507 (567 on this branch, 604 once the
  judge sandbox is merged too, so the claim holds either way).
- Slide 3: "chat sellers with no store of their own" instead of "no store system".
  The BPS data says chat is the default order inbox (95%) and few have their own
  website (1.8%), not that sellers have no store system (18% use marketplaces).
- Slide 13: the repository address.

Still open in the deck: team name and leader (slide 1), the demo video and Cloud Run
links (slide 13), and the TBD results in the benchmark table (slide 11).

Co-Authored-By: Claude Sonnet 5.5 <noreply@anthropic.com>
Claude-Session: https://claude.ai/code/session_01BGUUzgQcUZcRt5kdpoFMow
</commit_message>
<xml_diff>
--- a/submission/Etalase_AI_Builder_Cup_Submission.pptx
+++ b/submission/Etalase_AI_Builder_Cup_Submission.pptx
@@ -7222,7 +7222,7 @@
                 </a:solidFill>
                 <a:latin typeface="Google Sans Flex"/>
               </a:rPr>
-              <a:t>Screenshots of the running prototype with mock payment and courier. The seller account is created by us (sign-up and KYC are not built); product photos are synthetic samples.</a:t>
+              <a:t>Screenshots of the running prototype with mock payment and courier. Chat sign-up is built, the payment provider's identity check is not; the demo seller is ours. Product photos are synthetic samples.</a:t>
             </a:r>
           </a:p>
         </p:txBody>
@@ -7688,7 +7688,7 @@
                 </a:solidFill>
                 <a:latin typeface="Google Sans Flex"/>
               </a:rPr>
-              <a:t>507 automated tests pass today (stock races, payments, returns, webhooks, OTP abuse, fixes from an independent review) and an end-to-end run over real HTTP. TBD results come from the Gemini run on Cloud Run.</a:t>
+              <a:t>560+ automated tests pass today (stock races, payments, returns, webhooks, OTP abuse, fixes from an independent review) and an end-to-end run over real HTTP. TBD results come from the Gemini run on Cloud Run.</a:t>
             </a:r>
           </a:p>
         </p:txBody>
@@ -10102,7 +10102,7 @@
                 </a:solidFill>
                 <a:latin typeface="Google Sans Flex"/>
               </a:rPr>
-              <a:t>[Add GitHub link: github.com/&lt;team&gt;/etalase]</a:t>
+              <a:t>github.com/galihsatriawan/etalase</a:t>
             </a:r>
           </a:p>
         </p:txBody>
@@ -11680,7 +11680,7 @@
                 </a:solidFill>
                 <a:latin typeface="Google Sans Flex"/>
               </a:rPr>
-              <a:t>Etalase serves sellers with no store system: photos to catalog, a store link, MCP and UCP</a:t>
+              <a:t>Etalase serves chat sellers with no store of their own: photos to catalog, a store link, MCP and UCP</a:t>
             </a:r>
           </a:p>
         </p:txBody>
@@ -12129,7 +12129,7 @@
                 </a:solidFill>
                 <a:latin typeface="Google Sans Flex"/>
               </a:rPr>
-              <a:t>From WhatsApp photos to an agent-ready catalog with Gemini, no store system needed</a:t>
+              <a:t>From WhatsApp photos to an agent-ready catalog with Gemini, no store of your own needed</a:t>
             </a:r>
           </a:p>
           <a:p>

</xml_diff>

<commit_message>
Submission deck: team name and leader, the features added since, and honest benchmark cells
Team Prompt & Pray, leader Galih Anggi Satriawan. Slide 4 mentions per-shop addresses, chat sign-up and carts of several products. Slide 11 says 666 tests and the UCP conformance result, replaces the TBD cells with 'Not measured', and shows the offline-rules baseline of the extraction eval (21 of 43 cases fully correct) instead of an unmeasured target. The three video and product links on slide 13 are still to be filled.

Co-Authored-By: Claude Sonnet 5.5 <noreply@anthropic.com>
Claude-Session: https://claude.ai/code/session_01BGUUzgQcUZcRt5kdpoFMow
</commit_message>
<xml_diff>
--- a/submission/Etalase_AI_Builder_Cup_Submission.pptx
+++ b/submission/Etalase_AI_Builder_Cup_Submission.pptx
@@ -6863,7 +6863,7 @@
               <a:rPr sz="1800" b="1">
                 <a:latin typeface="Google Sans Flex"/>
               </a:rPr>
-              <a:t>[Your team name]</a:t>
+              <a:t>Prompt &amp; Pray</a:t>
             </a:r>
             <a:endParaRPr sz="1800">
               <a:latin typeface="Google Sans Flex"/>
@@ -6897,7 +6897,7 @@
               <a:rPr sz="1800" b="1">
                 <a:latin typeface="Google Sans Flex"/>
               </a:rPr>
-              <a:t>[Your full name]</a:t>
+              <a:t>Galih Anggi Satriawan</a:t>
             </a:r>
             <a:endParaRPr sz="1800">
               <a:latin typeface="Google Sans Flex"/>
@@ -7688,7 +7688,7 @@
                 </a:solidFill>
                 <a:latin typeface="Google Sans Flex"/>
               </a:rPr>
-              <a:t>560+ automated tests pass today (stock races, payments, returns, webhooks, OTP abuse, fixes from an independent review) and an end-to-end run over real HTTP. TBD results come from the Gemini run on Cloud Run.</a:t>
+              <a:t>666 automated tests pass (stock races, payments, returns, webhooks, OTP abuse), plus an end-to-end run over real HTTP and the official UCP conformance suite: 30 passed, 21 failed, 26 skipped. “Not measured” cells need the Gemini run on Cloud Run, which has not happened yet.</a:t>
             </a:r>
           </a:p>
         </p:txBody>
@@ -7703,17 +7703,17 @@
         </p:nvGraphicFramePr>
         <p:xfrm>
           <a:off x="356616" y="1536192"/>
-          <a:ext cx="8430768" cy="3383280"/>
+          <a:ext cx="8430767" cy="3383280"/>
         </p:xfrm>
         <a:graphic>
           <a:graphicData uri="http://schemas.openxmlformats.org/drawingml/2006/table">
             <a:tbl>
               <a:tblPr/>
               <a:tblGrid>
-                <a:gridCol w="2011680"/>
-                <a:gridCol w="3310128"/>
-                <a:gridCol w="1737360"/>
-                <a:gridCol w="1371600"/>
+                <a:gridCol w="1874519"/>
+                <a:gridCol w="2743200"/>
+                <a:gridCol w="1664208"/>
+                <a:gridCol w="2148840"/>
               </a:tblGrid>
               <a:tr h="310896">
                 <a:tc>
@@ -7858,7 +7858,7 @@
                           </a:solidFill>
                           <a:latin typeface="Google Sans Flex"/>
                         </a:rPr>
-                        <a:t>50 labelled products: title, variant, price, stock</a:t>
+                        <a:t>43 labelled seller messages: title, variant, price, stock</a:t>
                       </a:r>
                     </a:p>
                   </a:txBody>
@@ -7908,7 +7908,7 @@
                           </a:solidFill>
                           <a:latin typeface="Google Sans Flex"/>
                         </a:rPr>
-                        <a:t>TBD</a:t>
+                        <a:t>Rules only: 21/43 fully correct. Gemini not run</a:t>
                       </a:r>
                     </a:p>
                   </a:txBody>
@@ -8010,7 +8010,7 @@
                           </a:solidFill>
                           <a:latin typeface="Google Sans Flex"/>
                         </a:rPr>
-                        <a:t>TBD</a:t>
+                        <a:t>Not measured</a:t>
                       </a:r>
                     </a:p>
                   </a:txBody>
@@ -8112,7 +8112,7 @@
                           </a:solidFill>
                           <a:latin typeface="Google Sans Flex"/>
                         </a:rPr>
-                        <a:t>TBD</a:t>
+                        <a:t>Not measured</a:t>
                       </a:r>
                     </a:p>
                   </a:txBody>
@@ -8316,7 +8316,7 @@
                           </a:solidFill>
                           <a:latin typeface="Google Sans Flex"/>
                         </a:rPr>
-                        <a:t>TBD</a:t>
+                        <a:t>Not measured</a:t>
                       </a:r>
                     </a:p>
                   </a:txBody>
@@ -8572,7 +8572,7 @@
                           </a:solidFill>
                           <a:latin typeface="Google Sans Flex"/>
                         </a:rPr>
-                        <a:t>Intent accuracy on 100 real seller messages</a:t>
+                        <a:t>Intent accuracy on seller stock messages</a:t>
                       </a:r>
                     </a:p>
                   </a:txBody>
@@ -8622,7 +8622,7 @@
                           </a:solidFill>
                           <a:latin typeface="Google Sans Flex"/>
                         </a:rPr>
-                        <a:t>TBD</a:t>
+                        <a:t>Not measured</a:t>
                       </a:r>
                     </a:p>
                   </a:txBody>
@@ -12853,7 +12853,7 @@
                 </a:solidFill>
                 <a:latin typeface="Google Sans Flex"/>
               </a:rPr>
-              <a:t>Each shop speaks MCP, UCP and schema.org, scores 0–100 for agent readiness, and has a mobile store link for buyers without an agent.</a:t>
+              <a:t>Each shop has its own address, speaks MCP, UCP and schema.org, scores 0–100 for agent readiness, and has a store link for buyers without an agent.</a:t>
             </a:r>
           </a:p>
         </p:txBody>
@@ -13096,7 +13096,7 @@
                 </a:solidFill>
                 <a:latin typeface="Google Sans Flex"/>
               </a:rPr>
-              <a:t>An ADK agent updates stock and prices and handles orders and tracking, on WhatsApp or Telegram. Buttons never go through the model.</a:t>
+              <a:t>An ADK agent updates stock, prices and orders on WhatsApp or Telegram, and new sellers sign up in chat. Buttons never go through the model.</a:t>
             </a:r>
           </a:p>
         </p:txBody>
@@ -13339,7 +13339,7 @@
                 </a:solidFill>
                 <a:latin typeface="Google Sans Flex"/>
               </a:rPr>
-              <a:t>Stock is reserved at checkout and low-confidence stock is confirmed with the seller first: 0 units oversold when 100 buyers race.</a:t>
+              <a:t>A cart of up to 10 products is reserved all or nothing; uncertain stock is confirmed with the seller before payment. 0 oversold when 100 buyers race.</a:t>
             </a:r>
           </a:p>
         </p:txBody>

</xml_diff>

<commit_message>
Deck and pitch guide: say which door works today (MCP, store link) and which waits for Google's surfaces (UCP)
Slide 2 and the roadmap card say that any agent can buy over MCP today and that UCP is built and tested for Google's surfaces when they arrive.
Slide 7 no longer reads as if Gemini calls Etalase ('any MCP or UCP client, demo: Gemini'). Slide 3 drops the 'no store of their own' claim, as the docs did.
Pitch guide: Q55, why both MCP and UCP and whether AI Mode buys from us (no; Merchant Center UCP onboarding is US-only by invitation).

Co-Authored-By: Claude Sonnet 5.5 <noreply@anthropic.com>
Claude-Session: https://claude.ai/code/session_01BGUUzgQcUZcRt5kdpoFMow
</commit_message>
<xml_diff>
--- a/submission/Etalase_AI_Builder_Cup_Submission.pptx
+++ b/submission/Etalase_AI_Builder_Cup_Submission.pptx
@@ -9024,7 +9024,7 @@
                 </a:solidFill>
                 <a:latin typeface="Google Sans Flex"/>
               </a:rPr>
-              <a:t>MCP, UCP checkout, store links</a:t>
+              <a:t>MCP and store links live; UCP built and tested</a:t>
             </a:r>
           </a:p>
           <a:p>
@@ -10750,7 +10750,7 @@
                 </a:solidFill>
                 <a:latin typeface="Google Sans Flex"/>
               </a:rPr>
-              <a:t>Gemini builds the catalog from photos, voice notes and spreadsheets. Etalase publishes it over MCP, the UCP checkout API and a store link that works today without an agent, reserves stock, takes QRIS payments and holds the payout through a return window. The seller confirms and ships from WhatsApp or Telegram.</a:t>
+              <a:t>Gemini builds the catalog from photos, voice notes and spreadsheets. Etalase publishes it over MCP (any agent, today), UCP (for Google's surfaces, when they arrive) and a store link, reserves stock, takes QRIS payments and holds the payout through a return window. The seller confirms and ships from WhatsApp or Telegram.</a:t>
             </a:r>
           </a:p>
         </p:txBody>
@@ -11680,7 +11680,7 @@
                 </a:solidFill>
                 <a:latin typeface="Google Sans Flex"/>
               </a:rPr>
-              <a:t>Etalase serves chat sellers with no store of their own: photos to catalog, a store link, MCP and UCP</a:t>
+              <a:t>Etalase serves sellers who run on chat: photos to catalog, a store link, MCP and UCP</a:t>
             </a:r>
           </a:p>
         </p:txBody>
@@ -12129,7 +12129,7 @@
                 </a:solidFill>
                 <a:latin typeface="Google Sans Flex"/>
               </a:rPr>
-              <a:t>From WhatsApp photos to an agent-ready catalog with Gemini, no store of your own needed</a:t>
+              <a:t>From WhatsApp photos to an agent-ready catalog with Gemini, no site to build first</a:t>
             </a:r>
           </a:p>
           <a:p>
@@ -18020,7 +18020,7 @@
                 </a:solidFill>
                 <a:latin typeface="Google Sans Flex"/>
               </a:rPr>
-              <a:t>Gemini or any UCP / MCP client</a:t>
+              <a:t>Any MCP or UCP client (demo: Gemini)</a:t>
             </a:r>
           </a:p>
         </p:txBody>

</xml_diff>

<commit_message>
Slide 13: sandbox link and clickable links; demo video label says under 3 minutes
The reviewer sandbox is deployed on Cloud Run. Its address is now on slide 13 (the PDF is re-exported, with the repository and
sandbox links clickable), in JUDGES.md and in the alignment checklist. The video link is still a placeholder.

Co-Authored-By: Claude Sonnet 5.5 <noreply@anthropic.com>
Claude-Session: https://claude.ai/code/session_01BGUUzgQcUZcRt5kdpoFMow
</commit_message>
<xml_diff>
--- a/submission/Etalase_AI_Builder_Cup_Submission.pptx
+++ b/submission/Etalase_AI_Builder_Cup_Submission.pptx
@@ -10101,6 +10101,7 @@
                   <a:srgbClr val="1A73E8"/>
                 </a:solidFill>
                 <a:latin typeface="Google Sans Flex"/>
+                <a:hlinkClick r:id="rId5"/>
               </a:rPr>
               <a:t>github.com/galihsatriawan/etalase</a:t>
             </a:r>
@@ -10183,7 +10184,7 @@
                 </a:solidFill>
                 <a:latin typeface="Google Sans Flex"/>
               </a:rPr>
-              <a:t>Demo video (3 minutes)</a:t>
+              <a:t>Demo video (under 3 minutes)</a:t>
             </a:r>
           </a:p>
         </p:txBody>
@@ -10333,8 +10334,9 @@
                   <a:srgbClr val="1A73E8"/>
                 </a:solidFill>
                 <a:latin typeface="Google Sans Flex"/>
-              </a:rPr>
-              <a:t>[Add Cloud Run URL]</a:t>
+                <a:hlinkClick r:id="rId6"/>
+              </a:rPr>
+              <a:t>etalase-demo-2gzn7hbgwa-et.a.run.app/demo</a:t>
             </a:r>
           </a:p>
         </p:txBody>

</xml_diff>

<commit_message>
Docs and deck: the sandbox's demo shop answers on demo.etalase.site
The judge sandbox now has a wildcard domain (Google HTTPS load balancer, Certificate Manager
wildcard certificate, DNS at the registrar). JUDGES.md, SETUP.md and doc 14 say what was
checked (demo.etalase.site answers 200; an unclaimed name answers the app's own 404) and what
was not (that shop's own UCP profile on the host, the Cloudflare route). Slide 10 says the same.
Test count 725 -> 729 after the demo-address tests (README, learn pages, slide 11).

Co-Authored-By: Claude Sonnet 5.5 <noreply@anthropic.com>
Claude-Session: https://claude.ai/code/session_01BGUUzgQcUZcRt5kdpoFMow
</commit_message>
<xml_diff>
--- a/submission/Etalase_AI_Builder_Cup_Submission.pptx
+++ b/submission/Etalase_AI_Builder_Cup_Submission.pptx
@@ -7222,7 +7222,7 @@
                 </a:solidFill>
                 <a:latin typeface="Google Sans Flex"/>
               </a:rPr>
-              <a:t>Screenshots of the running prototype with mock payment and courier. Chat sign-up is built, the payment provider's identity check is not; the demo seller is ours. Product photos are synthetic samples.</a:t>
+              <a:t>Screenshots of the running prototype (mock payment and courier). The demo shop has its own address, demo.etalase.site. Chat sign-up is built but off in the sandbox; the payment provider's identity check is not built. Photos are synthetic samples.</a:t>
             </a:r>
           </a:p>
         </p:txBody>
@@ -7688,7 +7688,7 @@
                 </a:solidFill>
                 <a:latin typeface="Google Sans Flex"/>
               </a:rPr>
-              <a:t>725 tests pass (stock races, payments, returns, webhooks, OTP abuse), plus an end-to-end HTTP run and the official UCP suite: 31 of 77 in production mode, 54 in sandbox test mode, each failure explained. “Not measured” cells need the Gemini run on Cloud Run, not yet done.</a:t>
+              <a:t>729 tests pass (stock races, payments, returns, webhooks, OTP abuse), plus an end-to-end HTTP run and the official UCP suite: 31 of 77 in production mode, 54 in sandbox test mode, each failure explained. “Not measured” cells need the Gemini run on Cloud Run, not yet done.</a:t>
             </a:r>
           </a:p>
         </p:txBody>

</xml_diff>

<commit_message>
Show the load balancer in the architecture slide and docs; note the http redirect
Slide 7 gets a small "HTTPS load balancer, wildcard certificate" box on the buyer-agent path and a
footnote sentence; slide 8 lists it under Google Cloud runtime; the PDF is exported again. doc 03
(deployment), the known-gaps page (shop subdomains: demo shop only) and SETUP (the port-80 redirect
rule exists in the sandbox) say the same, and only what was checked.

Co-Authored-By: Claude Sonnet 5.5 <noreply@anthropic.com>
Claude-Session: https://claude.ai/code/session_01BGUUzgQcUZcRt5kdpoFMow
</commit_message>
<xml_diff>
--- a/submission/Etalase_AI_Builder_Cup_Submission.pptx
+++ b/submission/Etalase_AI_Builder_Cup_Submission.pptx
@@ -19002,7 +19002,7 @@
         <p:spPr>
           <a:xfrm>
             <a:off x="356616" y="4626864"/>
-            <a:ext cx="8430767" cy="256032"/>
+            <a:ext cx="8430767" cy="380000"/>
           </a:xfrm>
           <a:prstGeom prst="rect">
             <a:avLst/>
@@ -19023,7 +19023,66 @@
                 </a:solidFill>
                 <a:latin typeface="Google Sans Flex"/>
               </a:rPr>
-              <a:t>Solid = hackathon MVP · dashed = roadmap. Country pack = { currency, payment, shipping, tax } adapters: a new market adds one config entry, not a new core. Each seller has one stock owner: Etalase, the OMS or the store.</a:t>
+              <a:t>Solid = hackathon MVP · dashed = roadmap. Shop addresses (demo.etalase.site in the sandbox) enter through a Google HTTPS load balancer with a wildcard certificate; Cloud Run keeps its own URL too. Country pack = { currency, payment, shipping, tax } adapters: a new market adds one config entry, not a new core. Each seller has one stock owner: Etalase, the OMS or the store.</a:t>
+            </a:r>
+          </a:p>
+        </p:txBody>
+      </p:sp>
+      <p:sp>
+        <p:nvSpPr>
+          <p:cNvPr id="143" name="Load balancer"/>
+          <p:cNvSpPr/>
+          <p:nvPr/>
+        </p:nvSpPr>
+        <p:spPr>
+          <a:xfrm>
+            <a:off x="4667870" y="1622000"/>
+            <a:ext cx="2300000" cy="150000"/>
+          </a:xfrm>
+          <a:prstGeom prst="roundRect">
+            <a:avLst>
+              <a:gd name="adj" fmla="val 10714"/>
+            </a:avLst>
+          </a:prstGeom>
+          <a:solidFill>
+            <a:srgbClr val="FFFFFF"/>
+          </a:solidFill>
+          <a:ln w="9525">
+            <a:solidFill>
+              <a:srgbClr val="1A73E8"/>
+            </a:solidFill>
+          </a:ln>
+          <a:effectLst/>
+        </p:spPr>
+        <p:style>
+          <a:lnRef idx="1">
+            <a:schemeClr val="accent1"/>
+          </a:lnRef>
+          <a:fillRef idx="3">
+            <a:schemeClr val="accent1"/>
+          </a:fillRef>
+          <a:effectRef idx="2">
+            <a:schemeClr val="accent1"/>
+          </a:effectRef>
+          <a:fontRef idx="minor">
+            <a:schemeClr val="lt1"/>
+          </a:fontRef>
+        </p:style>
+        <p:txBody>
+          <a:bodyPr rtlCol="0" anchor="ctr" wrap="square" lIns="27432" rIns="27432" tIns="0" bIns="0">
+            <a:noAutofit/>
+          </a:bodyPr>
+          <a:lstStyle/>
+          <a:p>
+            <a:pPr algn="ctr"/>
+            <a:r>
+              <a:rPr sz="700" b="1" i="0">
+                <a:solidFill>
+                  <a:srgbClr val="202124"/>
+                </a:solidFill>
+                <a:latin typeface="Google Sans Flex"/>
+              </a:rPr>
+              <a:t>HTTPS load balancer · wildcard certificate</a:t>
             </a:r>
           </a:p>
         </p:txBody>
@@ -19664,6 +19723,27 @@
                 <a:latin typeface="Google Sans Flex"/>
               </a:rPr>
               <a:t>Secret Manager for every key</a:t>
+            </a:r>
+          </a:p>
+          <a:p>
+            <a:pPr algn="l" marL="128016" indent="-128016">
+              <a:spcAft>
+                <a:spcPts val="400"/>
+              </a:spcAft>
+              <a:buClr>
+                <a:srgbClr val="1A73E8"/>
+              </a:buClr>
+              <a:buFont typeface="Arial"/>
+              <a:buChar char="•"/>
+            </a:pPr>
+            <a:r>
+              <a:rPr sz="1000" b="0" i="0">
+                <a:solidFill>
+                  <a:srgbClr val="202124"/>
+                </a:solidFill>
+                <a:latin typeface="Google Sans Flex"/>
+              </a:rPr>
+              <a:t>Load balancer + wildcard TLS</a:t>
             </a:r>
           </a:p>
           <a:p>

</xml_diff>

<commit_message>
Record the tuned-prompt Gemini eval (98%) and the Flash-Lite comparison
Gemini 3.8 Flash with the prompt of PR #21: 42/43 cases fully correct (98%), up
from 36/43 (84%) with the first prompt. The prompt was changed using the first
run's misses and the second run is on the same 43 messages, so every page says
the 98% is not a held-out result. Questions asked when nothing was missing fell
from 27 to 3 and no stock number is invented any more.

Gemini 3.1 Flash-Lite with the same prompt: 36/43 (84%), 1.22 s per message. It
halved the price in one case, dropped stock numbers in three and missed a question,
so extraction stays on 3.8 Flash.

latest.md holds the baseline and both current-prompt runs; the first run moves to
first-prompt-gemini-3.8-flash.md. Slide 11, the deck PDF, doc 12, the README and the
learn pages carry the new numbers; the test count is 735.

Co-Authored-By: Claude Sonnet 5.5 <noreply@anthropic.com>
Claude-Session: https://claude.ai/code/session_01BGUUzgQcUZcRt5kdpoFMow
</commit_message>
<xml_diff>
--- a/submission/Etalase_AI_Builder_Cup_Submission.pptx
+++ b/submission/Etalase_AI_Builder_Cup_Submission.pptx
@@ -7688,7 +7688,7 @@
                 </a:solidFill>
                 <a:latin typeface="Google Sans Flex"/>
               </a:rPr>
-              <a:t>731 tests pass (stock races, payments, returns, webhooks, OTP abuse), plus an end-to-end HTTP run and the official UCP suite: 31 of 77 in production mode, 54 in sandbox test mode, each failure explained. Gemini ran on the 43 text messages only; “Not measured” cells were not run.</a:t>
+              <a:t>735 tests pass (stock races, payments, returns, webhooks, OTP abuse), plus an end-to-end HTTP run and the official UCP suite: 31 of 77 in production mode, 54 in sandbox test mode, each failure explained. Gemini ran on the 43 text messages only; “Not measured” cells were not run.</a:t>
             </a:r>
           </a:p>
         </p:txBody>
@@ -7908,7 +7908,7 @@
                           </a:solidFill>
                           <a:latin typeface="Google Sans Flex"/>
                         </a:rPr>
-                        <a:t>Gemini: 36/43 (84%). Rules: 21/43. Below target, text only</a:t>
+                        <a:t>Gemini 98% (42/43), tuned on this set; 84% before. Rules 49%</a:t>
                       </a:r>
                     </a:p>
                   </a:txBody>
@@ -8010,7 +8010,7 @@
                           </a:solidFill>
                           <a:latin typeface="Google Sans Flex"/>
                         </a:rPr>
-                        <a:t>Text only: median 5.6 s per message</a:t>
+                        <a:t>Text only: median 4.8 s per message</a:t>
                       </a:r>
                     </a:p>
                   </a:txBody>

</xml_diff>